<commit_message>
Reword the guide deck without the word "step"
Replace every occurrence of «خطوة/خطوات» in the slide text with task, stage
or waypoint wording, at the owner's request. Labels captured inside the
screenshots are unchanged.

Co-Authored-By: Claude Opus 5.5 <noreply@anthropic.com>
Claude-Session: https://claude.ai/code/session_01M3LucAQtjzwJzTVRKkJ1Vn
</commit_message>
<xml_diff>
--- a/documentation/guide/bahith-guide.pptx
+++ b/documentation/guide/bahith-guide.pptx
@@ -138,21 +138,21 @@
   <p:extLst>
     <p:ext uri="{521415D9-36F7-43E2-AB2F-B90AF26B5E84}">
       <p14:sectionLst xmlns:p14="http://schemas.microsoft.com/office/powerpoint/2010/main">
-        <p14:section name="المقدمة" id="{9620b81f-69ef-5c7b-98be-2a15ed1475e4}">
+        <p14:section name="المقدمة" id="{2cc50664-0518-b5d4-90d9-077a9fe3c4a9}">
           <p14:sldIdLst>
             <p14:sldId id="256"/>
             <p14:sldId id="257"/>
             <p14:sldId id="258"/>
           </p14:sldIdLst>
         </p14:section>
-        <p14:section name="البدء" id="{589db440-41c6-d3ee-cbe3-3f2454a6e635}">
+        <p14:section name="البدء" id="{e77a4415-21c1-fa00-725d-6488c7b0e79c}">
           <p14:sldIdLst>
             <p14:sldId id="259"/>
             <p14:sldId id="260"/>
             <p14:sldId id="261"/>
           </p14:sldIdLst>
         </p14:section>
-        <p14:section name="الشاشات" id="{e87ed267-5116-b903-45d7-a017a50162d3}">
+        <p14:section name="الشاشات" id="{11ff4dac-b1e6-dbe8-c900-9b4417cb35d3}">
           <p14:sldIdLst>
             <p14:sldId id="262"/>
             <p14:sldId id="263"/>
@@ -178,7 +178,7 @@
             <p14:sldId id="283"/>
           </p14:sldIdLst>
         </p14:section>
-        <p14:section name="الاستخدام" id="{d016bfa8-63ea-017d-3d63-b6e9562339b0}">
+        <p14:section name="الاستخدام" id="{3693fa84-faea-cf55-52ca-7fb44db55e7d}">
           <p14:sldIdLst>
             <p14:sldId id="284"/>
             <p14:sldId id="285"/>
@@ -5823,7 +5823,7 @@
                 <a:latin typeface="Noto Naskh Arabic"/>
                 <a:cs typeface="adwa-assalaf"/>
               </a:rPr>
-              <a:t>الخطوة القادمة ووكيلها، وزر تشغيلها بالمحرك المختار.</a:t>
+              <a:t>المهمة القادمة ووكيلها، وزر تشغيلها بالمحرك المختار.</a:t>
             </a:r>
             <a:endParaRPr lang="ar-AE" sz="1400" dirty="0"/>
           </a:p>
@@ -6973,7 +6973,7 @@
                 <a:latin typeface="Noto Naskh Arabic"/>
                 <a:cs typeface="adwa-assalaf"/>
               </a:rPr>
-              <a:t>كل خطوة</a:t>
+              <a:t>كل مهمة</a:t>
             </a:r>
             <a:endParaRPr lang="ar-AE" sz="1600" dirty="0"/>
           </a:p>
@@ -7457,7 +7457,7 @@
                 <a:latin typeface="Noto Naskh Arabic"/>
                 <a:cs typeface="adwa-assalaf"/>
               </a:rPr>
-              <a:t>تشغيل خطوة في الوضع اليدوي</a:t>
+              <a:t>التشغيل في الوضع اليدوي</a:t>
             </a:r>
             <a:endParaRPr lang="ar-AE" sz="3200" dirty="0"/>
           </a:p>
@@ -12980,7 +12980,7 @@
                 <a:latin typeface="Noto Naskh Arabic"/>
                 <a:cs typeface="adwa-assalaf"/>
               </a:rPr>
-              <a:t>الخطوات</a:t>
+              <a:t>المراحل</a:t>
             </a:r>
             <a:endParaRPr lang="ar-AE" sz="1600" dirty="0"/>
           </a:p>
@@ -13018,7 +13018,7 @@
                 <a:latin typeface="Noto Naskh Arabic"/>
                 <a:cs typeface="adwa-assalaf"/>
               </a:rPr>
-              <a:t>عدد الخطوات ومعرّف السير على كل بطاقة.</a:t>
+              <a:t>عدد المراحل ومعرّف السير على كل بطاقة.</a:t>
             </a:r>
             <a:endParaRPr lang="ar-AE" sz="1400" dirty="0"/>
           </a:p>
@@ -13158,7 +13158,7 @@
                 <a:latin typeface="Noto Naskh Arabic"/>
                 <a:cs typeface="adwa-assalaf"/>
               </a:rPr>
-              <a:t>نقرة تعرض الخطوات ووكلاءها وبواباتها.</a:t>
+              <a:t>نقرة تعرض المراحل ووكلاءها وبواباتها.</a:t>
             </a:r>
             <a:endParaRPr lang="ar-AE" sz="1400" dirty="0"/>
           </a:p>
@@ -18153,7 +18153,7 @@
                 <a:latin typeface="Noto Naskh Arabic"/>
                 <a:cs typeface="adwa-assalaf"/>
               </a:rPr>
-              <a:t>رحلة عمل في سبع خطوات</a:t>
+              <a:t>رحلة عمل في سبع محطات</a:t>
             </a:r>
             <a:endParaRPr lang="ar-AE" sz="3200" dirty="0"/>
           </a:p>
@@ -20615,7 +20615,7 @@
                 <a:latin typeface="Noto Naskh Arabic"/>
                 <a:cs typeface="adwa-assalaf"/>
               </a:rPr>
-              <a:t>ثم اختاروا المحرك، وشغّلوا الخطوة الأولى، واقرؤوا المخرج في الشاشة الجانبية</a:t>
+              <a:t>ثم اختاروا المحرك، وشغّلوا المهمة الأولى، واقرؤوا المخرج في الشاشة الجانبية</a:t>
             </a:r>
             <a:endParaRPr lang="ar-AE" sz="2000" dirty="0"/>
           </a:p>

</xml_diff>